<commit_message>
copy: remove em dashes from every user-facing surface
Bulk substitution across index.html, pages.py (the marketing-page shell
and copy), the four blog posts, README.md, docs/PITCH.md, and
docs/ARCHITECTURE.md. ' - ' (with surrounding spaces) replaces ' - ' and
bare em dashes collapse to '-'. PITCH and ARCHITECTURE PDFs/PPTX
re-rendered to pick up the source change.

Co-Authored-By: Claude Opus 4.7 <noreply@anthropic.com>
</commit_message>
<xml_diff>
--- a/docs/PITCH-editable.pptx
+++ b/docs/PITCH-editable.pptx
@@ -3280,7 +3280,7 @@
             </a:r>
             <a:r>
               <a:rPr/>
-              <a:t> — a few minutes to feel the magic.</a:t>
+              <a:t> - a few minutes to feel the magic.</a:t>
             </a:r>
           </a:p>
           <a:p>
@@ -3291,7 +3291,7 @@
             </a:r>
             <a:r>
               <a:rPr/>
-              <a:t> — monthly plan by indexed hours, self-serve via Stripe.</a:t>
+              <a:t> - monthly plan by indexed hours, self-serve via Stripe.</a:t>
             </a:r>
           </a:p>
           <a:p>
@@ -3302,7 +3302,7 @@
             </a:r>
             <a:r>
               <a:rPr/>
-              <a:t> — team seats, API access, on-prem / enterprise.</a:t>
+              <a:t> - team seats, API access, on-prem / enterprise.</a:t>
             </a:r>
           </a:p>
           <a:p>
@@ -3311,7 +3311,7 @@
             </a:pPr>
             <a:r>
               <a:rPr/>
-              <a:t>Cheap to run: one process, model and vector DB in-memory, fits on a single small instance — gross margin is on our side.</a:t>
+              <a:t>Cheap to run: one process, model and vector DB in-memory, fits on a single small instance - gross margin is on our side.</a:t>
             </a:r>
           </a:p>
         </p:txBody>
@@ -3462,7 +3462,7 @@
             </a:r>
             <a:r>
               <a:rPr/>
-              <a:t> — semantic, instant, on </a:t>
+              <a:t> - semantic, instant, on </a:t>
             </a:r>
             <a:r>
               <a:rPr i="1"/>
@@ -3544,7 +3544,7 @@
             </a:r>
             <a:r>
               <a:rPr/>
-              <a:t> — we search the pixels </a:t>
+              <a:t> - we search the pixels </a:t>
             </a:r>
             <a:r>
               <a:rPr i="1"/>
@@ -3563,7 +3563,7 @@
             </a:r>
             <a:r>
               <a:rPr/>
-              <a:t> — a shipped product, while most “AI video search” is still a waitlist.</a:t>
+              <a:t> - a shipped product, while most “AI video search” is still a waitlist.</a:t>
             </a:r>
           </a:p>
           <a:p>
@@ -3574,7 +3574,7 @@
             </a:r>
             <a:r>
               <a:rPr/>
-              <a:t> — the founder ships ML/embedding systems in production; the hard part is home turf.</a:t>
+              <a:t> - the founder ships ML/embedding systems in production; the hard part is home turf.</a:t>
             </a:r>
           </a:p>
           <a:p>
@@ -3585,7 +3585,7 @@
             </a:r>
             <a:r>
               <a:rPr/>
-              <a:t> — search, ask, chapters, reels off one index → widening surface area and switching cost.</a:t>
+              <a:t> - search, ask, chapters, reels off one index → widening surface area and switching cost.</a:t>
             </a:r>
           </a:p>
           <a:p>
@@ -3594,7 +3594,7 @@
             </a:pPr>
             <a:r>
               <a:rPr b="1"/>
-              <a:t>The capability is commoditizing — the product, polish, and data flywheel are not.</a:t>
+              <a:t>The capability is commoditizing - the product, polish, and data flywheel are not.</a:t>
             </a:r>
           </a:p>
         </p:txBody>
@@ -3670,7 +3670,7 @@
             </a:r>
             <a:r>
               <a:rPr/>
-              <a:t> — founder &amp; sole engineer · Oakland.</a:t>
+              <a:t> - founder &amp; sole engineer · Oakland.</a:t>
             </a:r>
           </a:p>
           <a:p>
@@ -3681,7 +3681,7 @@
             </a:r>
             <a:r>
               <a:rPr/>
-              <a:t> — ships </a:t>
+              <a:t> - ships </a:t>
             </a:r>
             <a:r>
               <a:rPr b="1"/>
@@ -3700,7 +3700,7 @@
             </a:r>
             <a:r>
               <a:rPr/>
-              <a:t> before tech — has lived the scrubbing problem first-hand.</a:t>
+              <a:t> before tech - has lived the scrubbing problem first-hand.</a:t>
             </a:r>
           </a:p>
           <a:p>
@@ -3726,7 +3726,7 @@
             </a:r>
             <a:r>
               <a:rPr/>
-              <a:t> — V1–V3, auth, and Stripe billing.</a:t>
+              <a:t> - V1–V3, auth, and Stripe billing.</a:t>
             </a:r>
           </a:p>
           <a:p>
@@ -3756,7 +3756,7 @@
             </a:r>
             <a:r>
               <a:rPr/>
-              <a:t> lived the problem it solves — rare founder-market fit for video.</a:t>
+              <a:t> lived the problem it solves - rare founder-market fit for video.</a:t>
             </a:r>
           </a:p>
         </p:txBody>
@@ -3832,7 +3832,7 @@
             </a:r>
             <a:r>
               <a:rPr/>
-              <a:t> Every clip, meeting, lecture, and archive — instantly searchable, anywhere it lives.</a:t>
+              <a:t> Every clip, meeting, lecture, and archive - instantly searchable, anywhere it lives.</a:t>
             </a:r>
           </a:p>
           <a:p>
@@ -3946,7 +3946,7 @@
             </a:r>
             <a:r>
               <a:rPr/>
-              <a:t> — and that’s one platform.</a:t>
+              <a:t> - and that’s one platform.</a:t>
             </a:r>
           </a:p>
           <a:p>
@@ -4000,7 +4000,7 @@
             </a:r>
             <a:r>
               <a:rPr/>
-              <a:t> the right footage — before a single cut.</a:t>
+              <a:t> the right footage - before a single cut.</a:t>
             </a:r>
           </a:p>
         </p:txBody>
@@ -4089,7 +4089,7 @@
             <a:pPr lvl="0"/>
             <a:r>
               <a:rPr/>
-              <a:t>Upload a video — or point Scrubless at a whole folder of them.</a:t>
+              <a:t>Upload a video - or point Scrubless at a whole folder of them.</a:t>
             </a:r>
           </a:p>
           <a:p>
@@ -4138,7 +4138,7 @@
             </a:r>
             <a:r>
               <a:rPr/>
-              <a:t> — not just captions.</a:t>
+              <a:t> - not just captions.</a:t>
             </a:r>
           </a:p>
         </p:txBody>
@@ -4185,7 +4185,7 @@
             </a:pPr>
             <a:r>
               <a:rPr/>
-              <a:t>Live today — and it works</a:t>
+              <a:t>Live today - and it works</a:t>
             </a:r>
           </a:p>
         </p:txBody>
@@ -4247,7 +4247,7 @@
             </a:pPr>
             <a:r>
               <a:rPr/>
-              <a:t>Real search on getscrubless.com: “the big rabbit” → ranked moments with match scores; click one, the player jumps to that second. Shipped to production — not a prototype.</a:t>
+              <a:t>Real search on getscrubless.com: “the big rabbit” → ranked moments with match scores; click one, the player jumps to that second. Shipped to production - not a prototype.</a:t>
             </a:r>
           </a:p>
         </p:txBody>
@@ -4458,7 +4458,7 @@
             </a:pPr>
             <a:r>
               <a:rPr/>
-              <a:t>Once a video is indexed, the hard part is done — everything else is free.</a:t>
+              <a:t>Once a video is indexed, the hard part is done - everything else is free.</a:t>
             </a:r>
           </a:p>
           <a:p>
@@ -4469,7 +4469,7 @@
             </a:r>
             <a:r>
               <a:rPr/>
-              <a:t> — search across an </a:t>
+              <a:t> - search across an </a:t>
             </a:r>
             <a:r>
               <a:rPr i="1"/>
@@ -4488,7 +4488,7 @@
             </a:r>
             <a:r>
               <a:rPr/>
-              <a:t> — questions answered in prose, with clickable cited timestamps.</a:t>
+              <a:t> - questions answered in prose, with clickable cited timestamps.</a:t>
             </a:r>
           </a:p>
           <a:p>
@@ -4510,7 +4510,7 @@
             </a:r>
             <a:r>
               <a:rPr/>
-              <a:t> — stitch the best moments into a shareable clip.</a:t>
+              <a:t> - stitch the best moments into a shareable clip.</a:t>
             </a:r>
           </a:p>
           <a:p>
@@ -4519,7 +4519,7 @@
             </a:pPr>
             <a:r>
               <a:rPr sz="2000"/>
-              <a:t>Index once. Search, ask, summarize, and cut — from the same index.</a:t>
+              <a:t>Index once. Search, ask, summarize, and cut - from the same index.</a:t>
             </a:r>
           </a:p>
         </p:txBody>
@@ -4644,7 +4644,7 @@
             </a:pPr>
             <a:r>
               <a:rPr b="1"/>
-              <a:t>The tech is finally ready — and we’ve already shipped on it.</a:t>
+              <a:t>The tech is finally ready - and we’ve already shipped on it.</a:t>
             </a:r>
           </a:p>
         </p:txBody>
@@ -4750,7 +4750,7 @@
             </a:r>
             <a:r>
               <a:rPr/>
-              <a:t> — the spend on making video findable.</a:t>
+              <a:t> - the spend on making video findable.</a:t>
             </a:r>
           </a:p>
           <a:p>
@@ -4807,7 +4807,7 @@
             </a:r>
             <a:r>
               <a:rPr/>
-              <a:t> DAM ≈$5B · search ≈$6B · video intelligence ≈$11B — same order of magnitude.</a:t>
+              <a:t> DAM ≈$5B · search ≈$6B · video intelligence ≈$11B - same order of magnitude.</a:t>
             </a:r>
           </a:p>
         </p:txBody>
@@ -4890,7 +4890,7 @@
             <a:pPr lvl="0"/>
             <a:r>
               <a:rPr/>
-              <a:t>V1 search, V2 library mode, V3 Q&amp;A / chapters / reels — all in production.</a:t>
+              <a:t>V1 search, V2 library mode, V3 Q&amp;A / chapters / reels - all in production.</a:t>
             </a:r>
           </a:p>
           <a:p>
@@ -4906,7 +4906,7 @@
             </a:pPr>
             <a:r>
               <a:rPr b="1"/>
-              <a:t>Targets — next two quarters, post public launch:</a:t>
+              <a:t>Targets - next two quarters, post public launch:</a:t>
             </a:r>
           </a:p>
           <a:p>

</xml_diff>

<commit_message>
copy: replace the em-dash-then-hyphen leftovers with commas; fix LinkedIn URL
The previous pass left awkward hyphens (" - ") in places em dashes used to
live. Replaced ' - ' with ', ' across every user-facing source, with a
non-space lookahead so markdown list bullets ('- ' at line start / nested)
are preserved. PITCH and ARCHITECTURE re-rendered.

Also: the LinkedIn URL on /about pointed at /in/ernest-opara, which is
not the real handle. Fixed to /in/chukwuebuka-ernest-opara.

Co-Authored-By: Claude Opus 4.7 <noreply@anthropic.com>
</commit_message>
<xml_diff>
--- a/docs/PITCH-editable.pptx
+++ b/docs/PITCH-editable.pptx
@@ -3280,7 +3280,7 @@
             </a:r>
             <a:r>
               <a:rPr/>
-              <a:t> - a few minutes to feel the magic.</a:t>
+              <a:t>, a few minutes to feel the magic.</a:t>
             </a:r>
           </a:p>
           <a:p>
@@ -3291,7 +3291,7 @@
             </a:r>
             <a:r>
               <a:rPr/>
-              <a:t> - monthly plan by indexed hours, self-serve via Stripe.</a:t>
+              <a:t>, monthly plan by indexed hours, self-serve via Stripe.</a:t>
             </a:r>
           </a:p>
           <a:p>
@@ -3302,7 +3302,7 @@
             </a:r>
             <a:r>
               <a:rPr/>
-              <a:t> - team seats, API access, on-prem / enterprise.</a:t>
+              <a:t>, team seats, API access, on-prem / enterprise.</a:t>
             </a:r>
           </a:p>
           <a:p>
@@ -3311,7 +3311,7 @@
             </a:pPr>
             <a:r>
               <a:rPr/>
-              <a:t>Cheap to run: one process, model and vector DB in-memory, fits on a single small instance - gross margin is on our side.</a:t>
+              <a:t>Cheap to run: one process, model and vector DB in-memory, fits on a single small instance, gross margin is on our side.</a:t>
             </a:r>
           </a:p>
         </p:txBody>
@@ -3462,7 +3462,7 @@
             </a:r>
             <a:r>
               <a:rPr/>
-              <a:t> - semantic, instant, on </a:t>
+              <a:t>, semantic, instant, on </a:t>
             </a:r>
             <a:r>
               <a:rPr i="1"/>
@@ -3544,7 +3544,7 @@
             </a:r>
             <a:r>
               <a:rPr/>
-              <a:t> - we search the pixels </a:t>
+              <a:t>, we search the pixels </a:t>
             </a:r>
             <a:r>
               <a:rPr i="1"/>
@@ -3563,7 +3563,7 @@
             </a:r>
             <a:r>
               <a:rPr/>
-              <a:t> - a shipped product, while most “AI video search” is still a waitlist.</a:t>
+              <a:t>, a shipped product, while most “AI video search” is still a waitlist.</a:t>
             </a:r>
           </a:p>
           <a:p>
@@ -3574,7 +3574,7 @@
             </a:r>
             <a:r>
               <a:rPr/>
-              <a:t> - the founder ships ML/embedding systems in production; the hard part is home turf.</a:t>
+              <a:t>, the founder ships ML/embedding systems in production; the hard part is home turf.</a:t>
             </a:r>
           </a:p>
           <a:p>
@@ -3585,7 +3585,7 @@
             </a:r>
             <a:r>
               <a:rPr/>
-              <a:t> - search, ask, chapters, reels off one index → widening surface area and switching cost.</a:t>
+              <a:t>, search, ask, chapters, reels off one index → widening surface area and switching cost.</a:t>
             </a:r>
           </a:p>
           <a:p>
@@ -3594,7 +3594,7 @@
             </a:pPr>
             <a:r>
               <a:rPr b="1"/>
-              <a:t>The capability is commoditizing - the product, polish, and data flywheel are not.</a:t>
+              <a:t>The capability is commoditizing, the product, polish, and data flywheel are not.</a:t>
             </a:r>
           </a:p>
         </p:txBody>
@@ -3670,7 +3670,7 @@
             </a:r>
             <a:r>
               <a:rPr/>
-              <a:t> - founder &amp; sole engineer · Oakland.</a:t>
+              <a:t>, founder &amp; sole engineer · Oakland.</a:t>
             </a:r>
           </a:p>
           <a:p>
@@ -3681,7 +3681,7 @@
             </a:r>
             <a:r>
               <a:rPr/>
-              <a:t> - ships </a:t>
+              <a:t>, ships </a:t>
             </a:r>
             <a:r>
               <a:rPr b="1"/>
@@ -3700,7 +3700,7 @@
             </a:r>
             <a:r>
               <a:rPr/>
-              <a:t> before tech - has lived the scrubbing problem first-hand.</a:t>
+              <a:t> before tech, has lived the scrubbing problem first-hand.</a:t>
             </a:r>
           </a:p>
           <a:p>
@@ -3726,7 +3726,7 @@
             </a:r>
             <a:r>
               <a:rPr/>
-              <a:t> - V1–V3, auth, and Stripe billing.</a:t>
+              <a:t>, V1–V3, auth, and Stripe billing.</a:t>
             </a:r>
           </a:p>
           <a:p>
@@ -3832,7 +3832,7 @@
             </a:r>
             <a:r>
               <a:rPr/>
-              <a:t> Every clip, meeting, lecture, and archive - instantly searchable, anywhere it lives.</a:t>
+              <a:t> Every clip, meeting, lecture, and archive, instantly searchable, anywhere it lives.</a:t>
             </a:r>
           </a:p>
           <a:p>
@@ -3946,7 +3946,7 @@
             </a:r>
             <a:r>
               <a:rPr/>
-              <a:t> - and that’s one platform.</a:t>
+              <a:t>, and that’s one platform.</a:t>
             </a:r>
           </a:p>
           <a:p>
@@ -4000,7 +4000,7 @@
             </a:r>
             <a:r>
               <a:rPr/>
-              <a:t> the right footage - before a single cut.</a:t>
+              <a:t> the right footage, before a single cut.</a:t>
             </a:r>
           </a:p>
         </p:txBody>
@@ -4089,7 +4089,7 @@
             <a:pPr lvl="0"/>
             <a:r>
               <a:rPr/>
-              <a:t>Upload a video - or point Scrubless at a whole folder of them.</a:t>
+              <a:t>Upload a video, or point Scrubless at a whole folder of them.</a:t>
             </a:r>
           </a:p>
           <a:p>
@@ -4138,7 +4138,7 @@
             </a:r>
             <a:r>
               <a:rPr/>
-              <a:t> - not just captions.</a:t>
+              <a:t>, not just captions.</a:t>
             </a:r>
           </a:p>
         </p:txBody>
@@ -4185,7 +4185,7 @@
             </a:pPr>
             <a:r>
               <a:rPr/>
-              <a:t>Live today - and it works</a:t>
+              <a:t>Live today, and it works</a:t>
             </a:r>
           </a:p>
         </p:txBody>
@@ -4247,7 +4247,7 @@
             </a:pPr>
             <a:r>
               <a:rPr/>
-              <a:t>Real search on getscrubless.com: “the big rabbit” → ranked moments with match scores; click one, the player jumps to that second. Shipped to production - not a prototype.</a:t>
+              <a:t>Real search on getscrubless.com: “the big rabbit” → ranked moments with match scores; click one, the player jumps to that second. Shipped to production, not a prototype.</a:t>
             </a:r>
           </a:p>
         </p:txBody>
@@ -4458,7 +4458,7 @@
             </a:pPr>
             <a:r>
               <a:rPr/>
-              <a:t>Once a video is indexed, the hard part is done - everything else is free.</a:t>
+              <a:t>Once a video is indexed, the hard part is done, everything else is free.</a:t>
             </a:r>
           </a:p>
           <a:p>
@@ -4469,7 +4469,7 @@
             </a:r>
             <a:r>
               <a:rPr/>
-              <a:t> - search across an </a:t>
+              <a:t>, search across an </a:t>
             </a:r>
             <a:r>
               <a:rPr i="1"/>
@@ -4488,7 +4488,7 @@
             </a:r>
             <a:r>
               <a:rPr/>
-              <a:t> - questions answered in prose, with clickable cited timestamps.</a:t>
+              <a:t>, questions answered in prose, with clickable cited timestamps.</a:t>
             </a:r>
           </a:p>
           <a:p>
@@ -4510,7 +4510,7 @@
             </a:r>
             <a:r>
               <a:rPr/>
-              <a:t> - stitch the best moments into a shareable clip.</a:t>
+              <a:t>, stitch the best moments into a shareable clip.</a:t>
             </a:r>
           </a:p>
           <a:p>
@@ -4519,7 +4519,7 @@
             </a:pPr>
             <a:r>
               <a:rPr sz="2000"/>
-              <a:t>Index once. Search, ask, summarize, and cut - from the same index.</a:t>
+              <a:t>Index once. Search, ask, summarize, and cut, from the same index.</a:t>
             </a:r>
           </a:p>
         </p:txBody>
@@ -4644,7 +4644,7 @@
             </a:pPr>
             <a:r>
               <a:rPr b="1"/>
-              <a:t>The tech is finally ready - and we’ve already shipped on it.</a:t>
+              <a:t>The tech is finally ready, and we’ve already shipped on it.</a:t>
             </a:r>
           </a:p>
         </p:txBody>
@@ -4750,7 +4750,7 @@
             </a:r>
             <a:r>
               <a:rPr/>
-              <a:t> - the spend on making video findable.</a:t>
+              <a:t>, the spend on making video findable.</a:t>
             </a:r>
           </a:p>
           <a:p>
@@ -4807,7 +4807,7 @@
             </a:r>
             <a:r>
               <a:rPr/>
-              <a:t> DAM ≈$5B · search ≈$6B · video intelligence ≈$11B - same order of magnitude.</a:t>
+              <a:t> DAM ≈$5B · search ≈$6B · video intelligence ≈$11B, same order of magnitude.</a:t>
             </a:r>
           </a:p>
         </p:txBody>
@@ -4890,7 +4890,7 @@
             <a:pPr lvl="0"/>
             <a:r>
               <a:rPr/>
-              <a:t>V1 search, V2 library mode, V3 Q&amp;A / chapters / reels - all in production.</a:t>
+              <a:t>V1 search, V2 library mode, V3 Q&amp;A / chapters / reels, all in production.</a:t>
             </a:r>
           </a:p>
           <a:p>
@@ -4906,7 +4906,7 @@
             </a:pPr>
             <a:r>
               <a:rPr b="1"/>
-              <a:t>Targets - next two quarters, post public launch:</a:t>
+              <a:t>Targets, next two quarters, post public launch:</a:t>
             </a:r>
           </a:p>
           <a:p>

</xml_diff>